<commit_message>
chore: PBS presentation - replace gold accents with black
</commit_message>
<xml_diff>
--- a/projects/pbs/pbs_site_launch.pptx
+++ b/projects/pbs/pbs_site_launch.pptx
@@ -3156,7 +3156,7 @@
             <a:avLst/>
           </a:prstGeom>
           <a:solidFill>
-            <a:srgbClr val="FFC72C"/>
+            <a:srgbClr val="000000"/>
           </a:solidFill>
           <a:ln>
             <a:noFill/>
@@ -3242,7 +3242,7 @@
             <a:avLst/>
           </a:prstGeom>
           <a:solidFill>
-            <a:srgbClr val="FFC72C"/>
+            <a:srgbClr val="000000"/>
           </a:solidFill>
           <a:ln>
             <a:noFill/>
@@ -3345,8 +3345,8 @@
         </p:nvSpPr>
         <p:spPr>
           <a:xfrm>
-            <a:off x="7132320" y="4206240"/>
-            <a:ext cx="4937760" cy="457200"/>
+            <a:off x="7132320" y="4251960"/>
+            <a:ext cx="4937760" cy="411480"/>
           </a:xfrm>
           <a:prstGeom prst="rect">
             <a:avLst/>
@@ -3433,7 +3433,7 @@
             <a:r>
               <a:rPr sz="1100" b="1" i="0">
                 <a:solidFill>
-                  <a:srgbClr val="FFC72C"/>
+                  <a:srgbClr val="BBCCFF"/>
                 </a:solidFill>
                 <a:latin typeface="Calibri"/>
               </a:rPr>
@@ -3487,13 +3487,13 @@
         <p:spPr>
           <a:xfrm>
             <a:off x="502920" y="3291840"/>
-            <a:ext cx="1280160" cy="54864"/>
+            <a:ext cx="1280160" cy="45720"/>
           </a:xfrm>
           <a:prstGeom prst="rect">
             <a:avLst/>
           </a:prstGeom>
           <a:solidFill>
-            <a:srgbClr val="FFC72C"/>
+            <a:srgbClr val="000000"/>
           </a:solidFill>
           <a:ln>
             <a:noFill/>
@@ -3547,7 +3547,7 @@
             <a:r>
               <a:rPr sz="1700" b="1" i="0">
                 <a:solidFill>
-                  <a:srgbClr val="FFC72C"/>
+                  <a:srgbClr val="FFFFFF"/>
                 </a:solidFill>
                 <a:latin typeface="Calibri"/>
               </a:rPr>
@@ -3582,7 +3582,7 @@
             <a:r>
               <a:rPr sz="1100" b="0" i="1">
                 <a:solidFill>
-                  <a:srgbClr val="CCDDFF"/>
+                  <a:srgbClr val="BBCCFF"/>
                 </a:solidFill>
                 <a:latin typeface="Calibri"/>
               </a:rPr>
@@ -3704,13 +3704,13 @@
         <p:spPr>
           <a:xfrm>
             <a:off x="0" y="1143000"/>
-            <a:ext cx="12188952" cy="64008"/>
+            <a:ext cx="12188952" cy="54864"/>
           </a:xfrm>
           <a:prstGeom prst="rect">
             <a:avLst/>
           </a:prstGeom>
           <a:solidFill>
-            <a:srgbClr val="FFC72C"/>
+            <a:srgbClr val="000000"/>
           </a:solidFill>
           <a:ln>
             <a:noFill/>
@@ -3754,8 +3754,8 @@
         </p:blipFill>
         <p:spPr>
           <a:xfrm>
-            <a:off x="182880" y="45720"/>
-            <a:ext cx="1005840" cy="1005840"/>
+            <a:off x="182880" y="73152"/>
+            <a:ext cx="960120" cy="960120"/>
           </a:xfrm>
           <a:prstGeom prst="rect">
             <a:avLst/>
@@ -3788,7 +3788,7 @@
             <a:r>
               <a:rPr sz="1000" b="1" i="0">
                 <a:solidFill>
-                  <a:srgbClr val="FFC72C"/>
+                  <a:srgbClr val="BBCCFF"/>
                 </a:solidFill>
                 <a:latin typeface="Calibri"/>
               </a:rPr>
@@ -3840,8 +3840,8 @@
         </p:nvSpPr>
         <p:spPr>
           <a:xfrm>
-            <a:off x="201168" y="1325880"/>
-            <a:ext cx="3822191" cy="5257800"/>
+            <a:off x="201168" y="1316736"/>
+            <a:ext cx="3822191" cy="5266944"/>
           </a:xfrm>
           <a:prstGeom prst="rect">
             <a:avLst/>
@@ -3885,7 +3885,7 @@
         </p:nvSpPr>
         <p:spPr>
           <a:xfrm>
-            <a:off x="201168" y="1325880"/>
+            <a:off x="201168" y="1316736"/>
             <a:ext cx="3822191" cy="566928"/>
           </a:xfrm>
           <a:prstGeom prst="rect">
@@ -4146,8 +4146,8 @@
         </p:nvSpPr>
         <p:spPr>
           <a:xfrm>
-            <a:off x="4206240" y="1325880"/>
-            <a:ext cx="3822191" cy="5257800"/>
+            <a:off x="4206240" y="1316736"/>
+            <a:ext cx="3822191" cy="5266944"/>
           </a:xfrm>
           <a:prstGeom prst="rect">
             <a:avLst/>
@@ -4191,7 +4191,7 @@
         </p:nvSpPr>
         <p:spPr>
           <a:xfrm>
-            <a:off x="4206240" y="1325880"/>
+            <a:off x="4206240" y="1316736"/>
             <a:ext cx="3822191" cy="566928"/>
           </a:xfrm>
           <a:prstGeom prst="rect">
@@ -4452,8 +4452,8 @@
         </p:nvSpPr>
         <p:spPr>
           <a:xfrm>
-            <a:off x="8229600" y="1325880"/>
-            <a:ext cx="3822191" cy="5257800"/>
+            <a:off x="8229600" y="1316736"/>
+            <a:ext cx="3822191" cy="5266944"/>
           </a:xfrm>
           <a:prstGeom prst="rect">
             <a:avLst/>
@@ -4497,7 +4497,7 @@
         </p:nvSpPr>
         <p:spPr>
           <a:xfrm>
-            <a:off x="8229600" y="1325880"/>
+            <a:off x="8229600" y="1316736"/>
             <a:ext cx="3822191" cy="566928"/>
           </a:xfrm>
           <a:prstGeom prst="rect">
@@ -4717,7 +4717,7 @@
             <a:avLst/>
           </a:prstGeom>
           <a:solidFill>
-            <a:srgbClr val="164F90"/>
+            <a:srgbClr val="000000"/>
           </a:solidFill>
           <a:ln>
             <a:noFill/>
@@ -4821,7 +4821,7 @@
             <a:avLst/>
           </a:prstGeom>
           <a:solidFill>
-            <a:srgbClr val="FFC72C"/>
+            <a:srgbClr val="000000"/>
           </a:solidFill>
           <a:ln>
             <a:noFill/>
@@ -4942,7 +4942,7 @@
             <a:r>
               <a:rPr sz="1000" b="1" i="0">
                 <a:solidFill>
-                  <a:srgbClr val="FFC72C"/>
+                  <a:srgbClr val="BBCCFF"/>
                 </a:solidFill>
                 <a:latin typeface="Calibri"/>
               </a:rPr>
@@ -4995,13 +4995,13 @@
         <p:spPr>
           <a:xfrm>
             <a:off x="411480" y="2651760"/>
-            <a:ext cx="1097280" cy="64008"/>
+            <a:ext cx="1097280" cy="54864"/>
           </a:xfrm>
           <a:prstGeom prst="rect">
             <a:avLst/>
           </a:prstGeom>
           <a:solidFill>
-            <a:srgbClr val="FFC72C"/>
+            <a:srgbClr val="000000"/>
           </a:solidFill>
           <a:ln>
             <a:noFill/>
@@ -5053,7 +5053,7 @@
           <a:p>
             <a:pPr>
               <a:spcAft>
-                <a:spcPts val="700"/>
+                <a:spcPts val="500"/>
               </a:spcAft>
             </a:pPr>
             <a:r>
@@ -5069,7 +5069,7 @@
           <a:p>
             <a:pPr>
               <a:spcAft>
-                <a:spcPts val="700"/>
+                <a:spcPts val="500"/>
               </a:spcAft>
             </a:pPr>
             <a:r>
@@ -5085,7 +5085,7 @@
           <a:p>
             <a:pPr>
               <a:spcAft>
-                <a:spcPts val="700"/>
+                <a:spcPts val="500"/>
               </a:spcAft>
             </a:pPr>
             <a:r>
@@ -5101,7 +5101,7 @@
           <a:p>
             <a:pPr>
               <a:spcAft>
-                <a:spcPts val="700"/>
+                <a:spcPts val="500"/>
               </a:spcAft>
             </a:pPr>
             <a:r>
@@ -5117,7 +5117,7 @@
           <a:p>
             <a:pPr>
               <a:spcAft>
-                <a:spcPts val="700"/>
+                <a:spcPts val="500"/>
               </a:spcAft>
             </a:pPr>
             <a:r>
@@ -5133,7 +5133,7 @@
           <a:p>
             <a:pPr>
               <a:spcAft>
-                <a:spcPts val="700"/>
+                <a:spcPts val="500"/>
               </a:spcAft>
             </a:pPr>
             <a:r>
@@ -5149,7 +5149,7 @@
           <a:p>
             <a:pPr>
               <a:spcAft>
-                <a:spcPts val="700"/>
+                <a:spcPts val="500"/>
               </a:spcAft>
             </a:pPr>
             <a:r>
@@ -5165,7 +5165,7 @@
           <a:p>
             <a:pPr>
               <a:spcAft>
-                <a:spcPts val="700"/>
+                <a:spcPts val="500"/>
               </a:spcAft>
             </a:pPr>
             <a:r>
@@ -5223,14 +5223,14 @@
         </p:nvSpPr>
         <p:spPr>
           <a:xfrm>
-            <a:off x="7132320" y="1280160"/>
-            <a:ext cx="914400" cy="54864"/>
+            <a:off x="7132320" y="1298448"/>
+            <a:ext cx="914400" cy="45720"/>
           </a:xfrm>
           <a:prstGeom prst="rect">
             <a:avLst/>
           </a:prstGeom>
           <a:solidFill>
-            <a:srgbClr val="FFC72C"/>
+            <a:srgbClr val="000000"/>
           </a:solidFill>
           <a:ln>
             <a:noFill/>
@@ -5266,7 +5266,7 @@
         </p:nvSpPr>
         <p:spPr>
           <a:xfrm>
-            <a:off x="7132320" y="1417320"/>
+            <a:off x="7132320" y="1435608"/>
             <a:ext cx="4846320" cy="411480"/>
           </a:xfrm>
           <a:prstGeom prst="rect">
@@ -5372,7 +5372,7 @@
           </a:solidFill>
           <a:ln w="12700">
             <a:solidFill>
-              <a:srgbClr val="164F90"/>
+              <a:srgbClr val="000000"/>
             </a:solidFill>
           </a:ln>
         </p:spPr>
@@ -5484,7 +5484,7 @@
             <a:avLst/>
           </a:prstGeom>
           <a:solidFill>
-            <a:srgbClr val="FFC72C"/>
+            <a:srgbClr val="000000"/>
           </a:solidFill>
           <a:ln>
             <a:noFill/>

</xml_diff>